<commit_message>
Replace ??? in schema and add missing quotes to enums
</commit_message>
<xml_diff>
--- a/spec/concepts/diagrams/InteractionOfModules.pptx
+++ b/spec/concepts/diagrams/InteractionOfModules.pptx
@@ -207,7 +207,7 @@
           <a:p>
             <a:fld id="{37CCF725-7468-4D3D-9E24-A16745BBBA77}" type="datetimeFigureOut">
               <a:rPr lang="de-DE" smtClean="0"/>
-              <a:t>12.05.2025</a:t>
+              <a:t>27.05.2025</a:t>
             </a:fld>
             <a:endParaRPr lang="de-DE"/>
           </a:p>
@@ -694,7 +694,7 @@
           <a:p>
             <a:fld id="{9A2764DB-E7DF-4EA7-A1AF-05A77C280FCA}" type="datetimeFigureOut">
               <a:rPr lang="de-DE" smtClean="0"/>
-              <a:t>12.05.2025</a:t>
+              <a:t>27.05.2025</a:t>
             </a:fld>
             <a:endParaRPr lang="de-DE"/>
           </a:p>
@@ -864,7 +864,7 @@
           <a:p>
             <a:fld id="{9A2764DB-E7DF-4EA7-A1AF-05A77C280FCA}" type="datetimeFigureOut">
               <a:rPr lang="de-DE" smtClean="0"/>
-              <a:t>12.05.2025</a:t>
+              <a:t>27.05.2025</a:t>
             </a:fld>
             <a:endParaRPr lang="de-DE"/>
           </a:p>
@@ -1044,7 +1044,7 @@
           <a:p>
             <a:fld id="{9A2764DB-E7DF-4EA7-A1AF-05A77C280FCA}" type="datetimeFigureOut">
               <a:rPr lang="de-DE" smtClean="0"/>
-              <a:t>12.05.2025</a:t>
+              <a:t>27.05.2025</a:t>
             </a:fld>
             <a:endParaRPr lang="de-DE"/>
           </a:p>
@@ -1214,7 +1214,7 @@
           <a:p>
             <a:fld id="{9A2764DB-E7DF-4EA7-A1AF-05A77C280FCA}" type="datetimeFigureOut">
               <a:rPr lang="de-DE" smtClean="0"/>
-              <a:t>12.05.2025</a:t>
+              <a:t>27.05.2025</a:t>
             </a:fld>
             <a:endParaRPr lang="de-DE"/>
           </a:p>
@@ -1460,7 +1460,7 @@
           <a:p>
             <a:fld id="{9A2764DB-E7DF-4EA7-A1AF-05A77C280FCA}" type="datetimeFigureOut">
               <a:rPr lang="de-DE" smtClean="0"/>
-              <a:t>12.05.2025</a:t>
+              <a:t>27.05.2025</a:t>
             </a:fld>
             <a:endParaRPr lang="de-DE"/>
           </a:p>
@@ -1692,7 +1692,7 @@
           <a:p>
             <a:fld id="{9A2764DB-E7DF-4EA7-A1AF-05A77C280FCA}" type="datetimeFigureOut">
               <a:rPr lang="de-DE" smtClean="0"/>
-              <a:t>12.05.2025</a:t>
+              <a:t>27.05.2025</a:t>
             </a:fld>
             <a:endParaRPr lang="de-DE"/>
           </a:p>
@@ -2059,7 +2059,7 @@
           <a:p>
             <a:fld id="{9A2764DB-E7DF-4EA7-A1AF-05A77C280FCA}" type="datetimeFigureOut">
               <a:rPr lang="de-DE" smtClean="0"/>
-              <a:t>12.05.2025</a:t>
+              <a:t>27.05.2025</a:t>
             </a:fld>
             <a:endParaRPr lang="de-DE"/>
           </a:p>
@@ -2177,7 +2177,7 @@
           <a:p>
             <a:fld id="{9A2764DB-E7DF-4EA7-A1AF-05A77C280FCA}" type="datetimeFigureOut">
               <a:rPr lang="de-DE" smtClean="0"/>
-              <a:t>12.05.2025</a:t>
+              <a:t>27.05.2025</a:t>
             </a:fld>
             <a:endParaRPr lang="de-DE"/>
           </a:p>
@@ -2272,7 +2272,7 @@
           <a:p>
             <a:fld id="{9A2764DB-E7DF-4EA7-A1AF-05A77C280FCA}" type="datetimeFigureOut">
               <a:rPr lang="de-DE" smtClean="0"/>
-              <a:t>12.05.2025</a:t>
+              <a:t>27.05.2025</a:t>
             </a:fld>
             <a:endParaRPr lang="de-DE"/>
           </a:p>
@@ -2549,7 +2549,7 @@
           <a:p>
             <a:fld id="{9A2764DB-E7DF-4EA7-A1AF-05A77C280FCA}" type="datetimeFigureOut">
               <a:rPr lang="de-DE" smtClean="0"/>
-              <a:t>12.05.2025</a:t>
+              <a:t>27.05.2025</a:t>
             </a:fld>
             <a:endParaRPr lang="de-DE"/>
           </a:p>
@@ -2806,7 +2806,7 @@
           <a:p>
             <a:fld id="{9A2764DB-E7DF-4EA7-A1AF-05A77C280FCA}" type="datetimeFigureOut">
               <a:rPr lang="de-DE" smtClean="0"/>
-              <a:t>12.05.2025</a:t>
+              <a:t>27.05.2025</a:t>
             </a:fld>
             <a:endParaRPr lang="de-DE"/>
           </a:p>
@@ -3019,7 +3019,7 @@
           <a:p>
             <a:fld id="{9A2764DB-E7DF-4EA7-A1AF-05A77C280FCA}" type="datetimeFigureOut">
               <a:rPr lang="de-DE" smtClean="0"/>
-              <a:t>12.05.2025</a:t>
+              <a:t>27.05.2025</a:t>
             </a:fld>
             <a:endParaRPr lang="de-DE"/>
           </a:p>
@@ -20485,6 +20485,57 @@
       </p:grpSpPr>
       <p:sp>
         <p:nvSpPr>
+          <p:cNvPr id="13" name="Ellipse 12">
+            <a:extLst>
+              <a:ext uri="{FF2B5EF4-FFF2-40B4-BE49-F238E27FC236}">
+                <a16:creationId xmlns:a16="http://schemas.microsoft.com/office/drawing/2014/main" id="{D3BE0895-1A2E-A661-6721-DB582614D7D0}"/>
+              </a:ext>
+            </a:extLst>
+          </p:cNvPr>
+          <p:cNvSpPr/>
+          <p:nvPr/>
+        </p:nvSpPr>
+        <p:spPr>
+          <a:xfrm>
+            <a:off x="6358597" y="1741932"/>
+            <a:ext cx="5341278" cy="2943024"/>
+          </a:xfrm>
+          <a:prstGeom prst="ellipse">
+            <a:avLst/>
+          </a:prstGeom>
+          <a:solidFill>
+            <a:schemeClr val="bg1">
+              <a:lumMod val="95000"/>
+            </a:schemeClr>
+          </a:solidFill>
+        </p:spPr>
+        <p:style>
+          <a:lnRef idx="2">
+            <a:schemeClr val="accent1">
+              <a:shade val="15000"/>
+            </a:schemeClr>
+          </a:lnRef>
+          <a:fillRef idx="1">
+            <a:schemeClr val="accent1"/>
+          </a:fillRef>
+          <a:effectRef idx="0">
+            <a:schemeClr val="accent1"/>
+          </a:effectRef>
+          <a:fontRef idx="minor">
+            <a:schemeClr val="lt1"/>
+          </a:fontRef>
+        </p:style>
+        <p:txBody>
+          <a:bodyPr rtlCol="0" anchor="ctr"/>
+          <a:lstStyle/>
+          <a:p>
+            <a:pPr algn="ctr"/>
+            <a:endParaRPr lang="de-DE"/>
+          </a:p>
+        </p:txBody>
+      </p:sp>
+      <p:sp>
+        <p:nvSpPr>
           <p:cNvPr id="126" name="Ellipse 125">
             <a:extLst>
               <a:ext uri="{FF2B5EF4-FFF2-40B4-BE49-F238E27FC236}">
@@ -24625,6 +24676,144 @@
           </a:fontRef>
         </p:style>
       </p:cxnSp>
+      <p:sp>
+        <p:nvSpPr>
+          <p:cNvPr id="6" name="Rechteck 5">
+            <a:extLst>
+              <a:ext uri="{FF2B5EF4-FFF2-40B4-BE49-F238E27FC236}">
+                <a16:creationId xmlns:a16="http://schemas.microsoft.com/office/drawing/2014/main" id="{00A75787-DA57-D4B6-274F-0F6C0D30F8BE}"/>
+              </a:ext>
+            </a:extLst>
+          </p:cNvPr>
+          <p:cNvSpPr/>
+          <p:nvPr/>
+        </p:nvSpPr>
+        <p:spPr>
+          <a:xfrm>
+            <a:off x="10404306" y="1605792"/>
+            <a:ext cx="180383" cy="574893"/>
+          </a:xfrm>
+          <a:prstGeom prst="rect">
+            <a:avLst/>
+          </a:prstGeom>
+        </p:spPr>
+        <p:style>
+          <a:lnRef idx="2">
+            <a:schemeClr val="accent1">
+              <a:shade val="15000"/>
+            </a:schemeClr>
+          </a:lnRef>
+          <a:fillRef idx="1">
+            <a:schemeClr val="accent1"/>
+          </a:fillRef>
+          <a:effectRef idx="0">
+            <a:schemeClr val="accent1"/>
+          </a:effectRef>
+          <a:fontRef idx="minor">
+            <a:schemeClr val="lt1"/>
+          </a:fontRef>
+        </p:style>
+        <p:txBody>
+          <a:bodyPr rtlCol="0" anchor="ctr"/>
+          <a:lstStyle/>
+          <a:p>
+            <a:pPr algn="ctr"/>
+            <a:endParaRPr lang="de-DE"/>
+          </a:p>
+        </p:txBody>
+      </p:sp>
+      <p:sp>
+        <p:nvSpPr>
+          <p:cNvPr id="11" name="Rechteck 10">
+            <a:extLst>
+              <a:ext uri="{FF2B5EF4-FFF2-40B4-BE49-F238E27FC236}">
+                <a16:creationId xmlns:a16="http://schemas.microsoft.com/office/drawing/2014/main" id="{D2A2FE93-C3FA-0A05-6A3B-E04644D0C616}"/>
+              </a:ext>
+            </a:extLst>
+          </p:cNvPr>
+          <p:cNvSpPr/>
+          <p:nvPr/>
+        </p:nvSpPr>
+        <p:spPr>
+          <a:xfrm>
+            <a:off x="10835147" y="1521001"/>
+            <a:ext cx="180383" cy="220931"/>
+          </a:xfrm>
+          <a:prstGeom prst="rect">
+            <a:avLst/>
+          </a:prstGeom>
+        </p:spPr>
+        <p:style>
+          <a:lnRef idx="2">
+            <a:schemeClr val="accent2">
+              <a:shade val="15000"/>
+            </a:schemeClr>
+          </a:lnRef>
+          <a:fillRef idx="1">
+            <a:schemeClr val="accent2"/>
+          </a:fillRef>
+          <a:effectRef idx="0">
+            <a:schemeClr val="accent2"/>
+          </a:effectRef>
+          <a:fontRef idx="minor">
+            <a:schemeClr val="lt1"/>
+          </a:fontRef>
+        </p:style>
+        <p:txBody>
+          <a:bodyPr rtlCol="0" anchor="ctr"/>
+          <a:lstStyle/>
+          <a:p>
+            <a:pPr algn="ctr"/>
+            <a:endParaRPr lang="de-DE"/>
+          </a:p>
+        </p:txBody>
+      </p:sp>
+      <p:sp>
+        <p:nvSpPr>
+          <p:cNvPr id="12" name="Rechteck 11">
+            <a:extLst>
+              <a:ext uri="{FF2B5EF4-FFF2-40B4-BE49-F238E27FC236}">
+                <a16:creationId xmlns:a16="http://schemas.microsoft.com/office/drawing/2014/main" id="{DF6A8B11-5AA2-96FC-06AB-6CA0E4067524}"/>
+              </a:ext>
+            </a:extLst>
+          </p:cNvPr>
+          <p:cNvSpPr/>
+          <p:nvPr/>
+        </p:nvSpPr>
+        <p:spPr>
+          <a:xfrm>
+            <a:off x="10835147" y="2070220"/>
+            <a:ext cx="180383" cy="220931"/>
+          </a:xfrm>
+          <a:prstGeom prst="rect">
+            <a:avLst/>
+          </a:prstGeom>
+        </p:spPr>
+        <p:style>
+          <a:lnRef idx="2">
+            <a:schemeClr val="accent2">
+              <a:shade val="15000"/>
+            </a:schemeClr>
+          </a:lnRef>
+          <a:fillRef idx="1">
+            <a:schemeClr val="accent2"/>
+          </a:fillRef>
+          <a:effectRef idx="0">
+            <a:schemeClr val="accent2"/>
+          </a:effectRef>
+          <a:fontRef idx="minor">
+            <a:schemeClr val="lt1"/>
+          </a:fontRef>
+        </p:style>
+        <p:txBody>
+          <a:bodyPr rtlCol="0" anchor="ctr"/>
+          <a:lstStyle/>
+          <a:p>
+            <a:pPr algn="ctr"/>
+            <a:endParaRPr lang="de-DE"/>
+          </a:p>
+        </p:txBody>
+      </p:sp>
     </p:spTree>
     <p:extLst>
       <p:ext uri="{BB962C8B-B14F-4D97-AF65-F5344CB8AC3E}">
@@ -30427,41 +30616,6 @@
                 <a:latin typeface="Consolas" panose="020B0609020204030204" pitchFamily="49" charset="0"/>
               </a:rPr>
               <a:t>ManagementPlaneFc</a:t>
-            </a:r>
-          </a:p>
-        </p:txBody>
-      </p:sp>
-      <p:sp>
-        <p:nvSpPr>
-          <p:cNvPr id="6" name="Textfeld 5">
-            <a:extLst>
-              <a:ext uri="{FF2B5EF4-FFF2-40B4-BE49-F238E27FC236}">
-                <a16:creationId xmlns:a16="http://schemas.microsoft.com/office/drawing/2014/main" id="{A44A8998-058C-2B1D-D901-032ED19F4C09}"/>
-              </a:ext>
-            </a:extLst>
-          </p:cNvPr>
-          <p:cNvSpPr txBox="1"/>
-          <p:nvPr/>
-        </p:nvSpPr>
-        <p:spPr>
-          <a:xfrm>
-            <a:off x="8243016" y="4563091"/>
-            <a:ext cx="748923" cy="369332"/>
-          </a:xfrm>
-          <a:prstGeom prst="rect">
-            <a:avLst/>
-          </a:prstGeom>
-          <a:noFill/>
-        </p:spPr>
-        <p:txBody>
-          <a:bodyPr wrap="none" rtlCol="0">
-            <a:spAutoFit/>
-          </a:bodyPr>
-          <a:lstStyle/>
-          <a:p>
-            <a:r>
-              <a:rPr lang="de-DE"/>
-              <a:t>uuid2</a:t>
             </a:r>
           </a:p>
         </p:txBody>

</xml_diff>